<commit_message>
Prosa tras la corrida larga y la doble compuerta (revision_c3_prosa.md, aprobada): veredicto de exp11 con imagen→texto de cuatro cortes y diez semillas y con la fila del protocolo con compuerta; CONTEXTO e INICIO al 22 de septiembre con los pendientes cerrados; deck: envolvente 2.9 a 5.5, cifras de imagen→texto con diez semillas y diapositiva final actualizada
</commit_message>
<xml_diff>
--- a/hallazgos_exp7_a_exp11.pptx
+++ b/hallazgos_exp7_a_exp11.pptx
@@ -3440,7 +3440,7 @@
               <a:defRPr sz="2800"/>
             </a:pPr>
             <a:r>
-              <a:t>Pendiente</a:t>
+              <a:t>Cerrado después del deck, y pendiente</a:t>
             </a:r>
           </a:p>
         </p:txBody>
@@ -3474,7 +3474,7 @@
               <a:defRPr sz="1400"/>
             </a:pPr>
             <a:r>
-              <a:t>• Fase 3: reescribir la prosa desactualizada de los README (exp7, exp8, exp9, exp10, marco teórico, deck)</a:t>
+              <a:t>• Fases 3 y 4: prosa reescrita con aprobación; la contradicción se resolvió restringiendo «no entrópico» al ruteo (salida 5.1)</a:t>
             </a:r>
           </a:p>
           <a:p>
@@ -3485,7 +3485,7 @@
               <a:defRPr sz="1400"/>
             </a:pPr>
             <a:r>
-              <a:t>• Fase 4: decidir entre las tres salidas para la contradicción entre «el directorio no es entrópico» y «el directorio es metamemoria» (recomendada: restringir la primera al ruteo)</a:t>
+              <a:t>• Exp11: banco de 40 consultas fuera de dominio (EHAM única 3, oráculo 2, protocolo 4); imagen→texto con los cuatro cortes: la cobertura del especialista sube 0 → 79 % con N</a:t>
             </a:r>
           </a:p>
           <a:p>
@@ -3496,7 +3496,7 @@
               <a:defRPr sz="1400"/>
             </a:pPr>
             <a:r>
-              <a:t>• Exp11: banco fuera de dominio de ~40 consultas (2 contra 3 de 12 no separa nada); imagen→texto con los cuatro cortes si se quiere la versión larga</a:t>
+              <a:t>• Doble compuerta de contenido en la fase madura textual: el protocolo baja a 2/40, el nivel del oráculo; etapa 8 sigue 16/16</a:t>
             </a:r>
           </a:p>
           <a:p>
@@ -3507,7 +3507,7 @@
               <a:defRPr sz="1400"/>
             </a:pPr>
             <a:r>
-              <a:t>• Experimento barato que cerraría «mejor en dominios solapados»: los mismos tres brazos con pares de clases elegidos por distancia entre centroides</a:t>
+              <a:t>• Exp12: la brecha crece con el solapamiento de soportes en etiquetas (ρ 0.45, p 0.017); las 28 brechas son positivas</a:t>
             </a:r>
           </a:p>
           <a:p>
@@ -3518,7 +3518,18 @@
               <a:defRPr sz="1400"/>
             </a:pPr>
             <a:r>
-              <a:t>• App: migrar la fase temprana en vivo a directorios perspectivales; restaurar los modelos v5 en models/</a:t>
+              <a:t>• App: fase temprana en vivo con directorios perspectivales; modelos v5 en models/</a:t>
+            </a:r>
+          </a:p>
+          <a:p>
+            <a:pPr>
+              <a:spcAft>
+                <a:spcPts val="600"/>
+              </a:spcAft>
+              <a:defRPr sz="1400"/>
+            </a:pPr>
+            <a:r>
+              <a:t>• Pendiente: costo de la compuerta sobre el banco reservado; deck externo de Drive</a:t>
             </a:r>
           </a:p>
         </p:txBody>
@@ -3889,7 +3900,7 @@
               <a:defRPr sz="1300"/>
             </a:pPr>
             <a:r>
-              <a:t>• Lo recuperado es una envolvente, no una copia: vecino real y centroide siempre de la clase pedida, pero 2.9 a 5.9 veces más lejos de cualquier instancia que las instancias entre sí</a:t>
+              <a:t>• Lo recuperado es una envolvente, no una copia: vecino real y centroide siempre de la clase pedida, pero 2.9 a 5.5 veces más lejos de cualquier instancia que las instancias entre sí</a:t>
             </a:r>
           </a:p>
           <a:p>
@@ -4735,7 +4746,7 @@
                         <a:defRPr sz="1300"/>
                       </a:pPr>
                       <a:r>
-                        <a:t>92</a:t>
+                        <a:t>91</a:t>
                       </a:r>
                     </a:p>
                   </a:txBody>
@@ -4750,7 +4761,7 @@
                         <a:defRPr sz="1300"/>
                       </a:pPr>
                       <a:r>
-                        <a:t>99</a:t>
+                        <a:t>98</a:t>
                       </a:r>
                     </a:p>
                   </a:txBody>
@@ -4797,7 +4808,7 @@
                         <a:defRPr sz="1300"/>
                       </a:pPr>
                       <a:r>
-                        <a:t>8</a:t>
+                        <a:t>9</a:t>
                       </a:r>
                     </a:p>
                   </a:txBody>
@@ -4827,7 +4838,7 @@
                         <a:defRPr sz="1300"/>
                       </a:pPr>
                       <a:r>
-                        <a:t>1</a:t>
+                        <a:t>2</a:t>
                       </a:r>
                     </a:p>
                   </a:txBody>
@@ -5060,7 +5071,7 @@
               <a:defRPr sz="1300"/>
             </a:pPr>
             <a:r>
-              <a:t>• En imagen→texto la EHAM única cubre más (96 vs 79) porque el containment del especialista es estricto en 64 coordenadas; el rechazo residual del 25% que reportaba la tesis es un costo de partir, no de la memoria</a:t>
+              <a:t>• En imagen→texto la EHAM única cubre más (96 vs 79) porque el containment del especialista es estricto en 64 coordenadas; la cobertura de los dos sube con N (el especialista 0 → 79 %, la EHAM única 5 → 96 %) y el rechazo residual del 25% que reportaba la tesis es un costo de partir, no de la memoria</a:t>
             </a:r>
           </a:p>
           <a:p>

</xml_diff>